<commit_message>
Checkpoint antes de convertir código Go a Node.js en día 2 Módulo 4
</commit_message>
<xml_diff>
--- a/docs/slides/Modulo 4/dia1_anexo.pptx
+++ b/docs/slides/Modulo 4/dia1_anexo.pptx
@@ -316,7 +316,7 @@
           <a:p>
             <a:fld id="{5BCAD085-E8A6-8845-BD4E-CB4CCA059FC4}" type="datetimeFigureOut">
               <a:rPr lang="en-US" smtClean="0"/>
-              <a:t>4/13/2026</a:t>
+              <a:t>4/23/2026</a:t>
             </a:fld>
             <a:endParaRPr lang="en-US"/>
           </a:p>
@@ -484,7 +484,7 @@
           <a:p>
             <a:fld id="{5BCAD085-E8A6-8845-BD4E-CB4CCA059FC4}" type="datetimeFigureOut">
               <a:rPr lang="en-US" smtClean="0"/>
-              <a:t>4/13/2026</a:t>
+              <a:t>4/23/2026</a:t>
             </a:fld>
             <a:endParaRPr lang="en-US"/>
           </a:p>
@@ -662,7 +662,7 @@
           <a:p>
             <a:fld id="{5BCAD085-E8A6-8845-BD4E-CB4CCA059FC4}" type="datetimeFigureOut">
               <a:rPr lang="en-US" smtClean="0"/>
-              <a:t>4/13/2026</a:t>
+              <a:t>4/23/2026</a:t>
             </a:fld>
             <a:endParaRPr lang="en-US"/>
           </a:p>
@@ -830,7 +830,7 @@
           <a:p>
             <a:fld id="{5BCAD085-E8A6-8845-BD4E-CB4CCA059FC4}" type="datetimeFigureOut">
               <a:rPr lang="en-US" smtClean="0"/>
-              <a:t>4/13/2026</a:t>
+              <a:t>4/23/2026</a:t>
             </a:fld>
             <a:endParaRPr lang="en-US"/>
           </a:p>
@@ -1075,7 +1075,7 @@
           <a:p>
             <a:fld id="{5BCAD085-E8A6-8845-BD4E-CB4CCA059FC4}" type="datetimeFigureOut">
               <a:rPr lang="en-US" smtClean="0"/>
-              <a:t>4/13/2026</a:t>
+              <a:t>4/23/2026</a:t>
             </a:fld>
             <a:endParaRPr lang="en-US"/>
           </a:p>
@@ -1360,7 +1360,7 @@
           <a:p>
             <a:fld id="{5BCAD085-E8A6-8845-BD4E-CB4CCA059FC4}" type="datetimeFigureOut">
               <a:rPr lang="en-US" smtClean="0"/>
-              <a:t>4/13/2026</a:t>
+              <a:t>4/23/2026</a:t>
             </a:fld>
             <a:endParaRPr lang="en-US"/>
           </a:p>
@@ -1779,7 +1779,7 @@
           <a:p>
             <a:fld id="{5BCAD085-E8A6-8845-BD4E-CB4CCA059FC4}" type="datetimeFigureOut">
               <a:rPr lang="en-US" smtClean="0"/>
-              <a:t>4/13/2026</a:t>
+              <a:t>4/23/2026</a:t>
             </a:fld>
             <a:endParaRPr lang="en-US"/>
           </a:p>
@@ -1896,7 +1896,7 @@
           <a:p>
             <a:fld id="{5BCAD085-E8A6-8845-BD4E-CB4CCA059FC4}" type="datetimeFigureOut">
               <a:rPr lang="en-US" smtClean="0"/>
-              <a:t>4/13/2026</a:t>
+              <a:t>4/23/2026</a:t>
             </a:fld>
             <a:endParaRPr lang="en-US"/>
           </a:p>
@@ -1991,7 +1991,7 @@
           <a:p>
             <a:fld id="{5BCAD085-E8A6-8845-BD4E-CB4CCA059FC4}" type="datetimeFigureOut">
               <a:rPr lang="en-US" smtClean="0"/>
-              <a:t>4/13/2026</a:t>
+              <a:t>4/23/2026</a:t>
             </a:fld>
             <a:endParaRPr lang="en-US"/>
           </a:p>
@@ -2266,7 +2266,7 @@
           <a:p>
             <a:fld id="{5BCAD085-E8A6-8845-BD4E-CB4CCA059FC4}" type="datetimeFigureOut">
               <a:rPr lang="en-US" smtClean="0"/>
-              <a:t>4/13/2026</a:t>
+              <a:t>4/23/2026</a:t>
             </a:fld>
             <a:endParaRPr lang="en-US"/>
           </a:p>
@@ -2518,7 +2518,7 @@
           <a:p>
             <a:fld id="{5BCAD085-E8A6-8845-BD4E-CB4CCA059FC4}" type="datetimeFigureOut">
               <a:rPr lang="en-US" smtClean="0"/>
-              <a:t>4/13/2026</a:t>
+              <a:t>4/23/2026</a:t>
             </a:fld>
             <a:endParaRPr lang="en-US"/>
           </a:p>
@@ -2729,7 +2729,7 @@
           <a:p>
             <a:fld id="{5BCAD085-E8A6-8845-BD4E-CB4CCA059FC4}" type="datetimeFigureOut">
               <a:rPr lang="en-US" smtClean="0"/>
-              <a:t>4/13/2026</a:t>
+              <a:t>4/23/2026</a:t>
             </a:fld>
             <a:endParaRPr lang="en-US"/>
           </a:p>
@@ -7606,196 +7606,36 @@
           </a:p>
         </p:txBody>
       </p:sp>
-      <p:sp>
-        <p:nvSpPr>
-          <p:cNvPr id="5" name="Rectangle 4"/>
-          <p:cNvSpPr/>
+      <p:pic>
+        <p:nvPicPr>
+          <p:cNvPr id="11" name="Imagen 10">
+            <a:extLst>
+              <a:ext uri="{FF2B5EF4-FFF2-40B4-BE49-F238E27FC236}">
+                <a16:creationId xmlns:a16="http://schemas.microsoft.com/office/drawing/2014/main" id="{D59DBE3F-BD59-64A7-9EA0-2D41F516CB19}"/>
+              </a:ext>
+            </a:extLst>
+          </p:cNvPr>
+          <p:cNvPicPr>
+            <a:picLocks noChangeAspect="1"/>
+          </p:cNvPicPr>
           <p:nvPr/>
-        </p:nvSpPr>
+        </p:nvPicPr>
+        <p:blipFill>
+          <a:blip r:embed="rId2"/>
+          <a:stretch>
+            <a:fillRect/>
+          </a:stretch>
+        </p:blipFill>
         <p:spPr>
           <a:xfrm>
-            <a:off x="1371600" y="1371600"/>
-            <a:ext cx="9418320" cy="4114800"/>
+            <a:off x="1961090" y="1360448"/>
+            <a:ext cx="8266644" cy="5497552"/>
           </a:xfrm>
           <a:prstGeom prst="rect">
             <a:avLst/>
           </a:prstGeom>
-          <a:solidFill>
-            <a:srgbClr val="F2F2F2"/>
-          </a:solidFill>
-          <a:ln>
-            <a:noFill/>
-          </a:ln>
         </p:spPr>
-        <p:style>
-          <a:lnRef idx="1">
-            <a:schemeClr val="accent1"/>
-          </a:lnRef>
-          <a:fillRef idx="3">
-            <a:schemeClr val="accent1"/>
-          </a:fillRef>
-          <a:effectRef idx="2">
-            <a:schemeClr val="accent1"/>
-          </a:effectRef>
-          <a:fontRef idx="minor">
-            <a:schemeClr val="lt1"/>
-          </a:fontRef>
-        </p:style>
-        <p:txBody>
-          <a:bodyPr rtlCol="0" anchor="ctr"/>
-          <a:lstStyle/>
-          <a:p>
-            <a:pPr algn="ctr"/>
-            <a:endParaRPr/>
-          </a:p>
-        </p:txBody>
-      </p:sp>
-      <p:sp>
-        <p:nvSpPr>
-          <p:cNvPr id="6" name="TextBox 5"/>
-          <p:cNvSpPr txBox="1"/>
-          <p:nvPr/>
-        </p:nvSpPr>
-        <p:spPr>
-          <a:xfrm>
-            <a:off x="1828800" y="2286000"/>
-            <a:ext cx="8503920" cy="1371600"/>
-          </a:xfrm>
-          <a:prstGeom prst="rect">
-            <a:avLst/>
-          </a:prstGeom>
-          <a:noFill/>
-        </p:spPr>
-        <p:txBody>
-          <a:bodyPr wrap="square"/>
-          <a:lstStyle/>
-          <a:p>
-            <a:pPr algn="ctr">
-              <a:defRPr sz="2400" b="0">
-                <a:solidFill>
-                  <a:srgbClr val="999999"/>
-                </a:solidFill>
-                <a:latin typeface="Calibri"/>
-              </a:defRPr>
-            </a:pPr>
-            <a:r>
-              <a:t>[Diagrama: App cliente -&gt; Gateway -&gt; Peer (chaincode token) -&gt; World State (balances)]</a:t>
-            </a:r>
-          </a:p>
-        </p:txBody>
-      </p:sp>
-      <p:sp>
-        <p:nvSpPr>
-          <p:cNvPr id="7" name="Rectangle 6"/>
-          <p:cNvSpPr/>
-          <p:nvPr/>
-        </p:nvSpPr>
-        <p:spPr>
-          <a:xfrm>
-            <a:off x="1371600" y="3840480"/>
-            <a:ext cx="9418320" cy="320040"/>
-          </a:xfrm>
-          <a:prstGeom prst="rect">
-            <a:avLst/>
-          </a:prstGeom>
-          <a:solidFill>
-            <a:srgbClr val="7C3AED"/>
-          </a:solidFill>
-          <a:ln>
-            <a:noFill/>
-          </a:ln>
-        </p:spPr>
-        <p:style>
-          <a:lnRef idx="1">
-            <a:schemeClr val="accent1"/>
-          </a:lnRef>
-          <a:fillRef idx="3">
-            <a:schemeClr val="accent1"/>
-          </a:fillRef>
-          <a:effectRef idx="2">
-            <a:schemeClr val="accent1"/>
-          </a:effectRef>
-          <a:fontRef idx="minor">
-            <a:schemeClr val="lt1"/>
-          </a:fontRef>
-        </p:style>
-        <p:txBody>
-          <a:bodyPr rtlCol="0" anchor="ctr"/>
-          <a:lstStyle/>
-          <a:p>
-            <a:pPr algn="ctr"/>
-            <a:endParaRPr/>
-          </a:p>
-        </p:txBody>
-      </p:sp>
-      <p:sp>
-        <p:nvSpPr>
-          <p:cNvPr id="8" name="TextBox 7"/>
-          <p:cNvSpPr txBox="1"/>
-          <p:nvPr/>
-        </p:nvSpPr>
-        <p:spPr>
-          <a:xfrm>
-            <a:off x="1371600" y="3840480"/>
-            <a:ext cx="9418320" cy="320040"/>
-          </a:xfrm>
-          <a:prstGeom prst="rect">
-            <a:avLst/>
-          </a:prstGeom>
-          <a:noFill/>
-        </p:spPr>
-        <p:txBody>
-          <a:bodyPr wrap="square"/>
-          <a:lstStyle/>
-          <a:p>
-            <a:pPr algn="ctr">
-              <a:defRPr sz="1300" b="1">
-                <a:solidFill>
-                  <a:srgbClr val="FFFFFF"/>
-                </a:solidFill>
-                <a:latin typeface="Calibri"/>
-              </a:defRPr>
-            </a:pPr>
-            <a:r>
-              <a:t>Prompt para IA generativa:</a:t>
-            </a:r>
-          </a:p>
-        </p:txBody>
-      </p:sp>
-      <p:sp>
-        <p:nvSpPr>
-          <p:cNvPr id="9" name="TextBox 8"/>
-          <p:cNvSpPr txBox="1"/>
-          <p:nvPr/>
-        </p:nvSpPr>
-        <p:spPr>
-          <a:xfrm>
-            <a:off x="1645920" y="4297680"/>
-            <a:ext cx="8869680" cy="914400"/>
-          </a:xfrm>
-          <a:prstGeom prst="rect">
-            <a:avLst/>
-          </a:prstGeom>
-          <a:noFill/>
-        </p:spPr>
-        <p:txBody>
-          <a:bodyPr wrap="square"/>
-          <a:lstStyle/>
-          <a:p>
-            <a:pPr algn="l">
-              <a:defRPr sz="1400" b="0">
-                <a:solidFill>
-                  <a:srgbClr val="7C3AED"/>
-                </a:solidFill>
-                <a:latin typeface="Consolas"/>
-              </a:defRPr>
-            </a:pPr>
-            <a:r>
-              <a:t>Technical diagram showing token flow in Hyperledger Fabric: client app sends transaction proposal through Fabric Gateway to endorsing peer, chaincode executes token logic, world state updates balances. Clean flat design, dark teal color scheme, labeled arrows between components.</a:t>
-            </a:r>
-          </a:p>
-        </p:txBody>
-      </p:sp>
+      </p:pic>
     </p:spTree>
   </p:cSld>
   <p:clrMapOvr>
@@ -8894,196 +8734,36 @@
           </a:p>
         </p:txBody>
       </p:sp>
-      <p:sp>
-        <p:nvSpPr>
-          <p:cNvPr id="5" name="Rectangle 4"/>
-          <p:cNvSpPr/>
+      <p:pic>
+        <p:nvPicPr>
+          <p:cNvPr id="11" name="Imagen 10">
+            <a:extLst>
+              <a:ext uri="{FF2B5EF4-FFF2-40B4-BE49-F238E27FC236}">
+                <a16:creationId xmlns:a16="http://schemas.microsoft.com/office/drawing/2014/main" id="{7B63A9F1-61A6-9182-E61C-E8A166EF9EF6}"/>
+              </a:ext>
+            </a:extLst>
+          </p:cNvPr>
+          <p:cNvPicPr>
+            <a:picLocks noChangeAspect="1"/>
+          </p:cNvPicPr>
           <p:nvPr/>
-        </p:nvSpPr>
+        </p:nvPicPr>
+        <p:blipFill>
+          <a:blip r:embed="rId2"/>
+          <a:stretch>
+            <a:fillRect/>
+          </a:stretch>
+        </p:blipFill>
         <p:spPr>
           <a:xfrm>
-            <a:off x="1371600" y="1371600"/>
-            <a:ext cx="9418320" cy="4114800"/>
+            <a:off x="2676834" y="1626268"/>
+            <a:ext cx="6835156" cy="4542166"/>
           </a:xfrm>
           <a:prstGeom prst="rect">
             <a:avLst/>
           </a:prstGeom>
-          <a:solidFill>
-            <a:srgbClr val="F2F2F2"/>
-          </a:solidFill>
-          <a:ln>
-            <a:noFill/>
-          </a:ln>
         </p:spPr>
-        <p:style>
-          <a:lnRef idx="1">
-            <a:schemeClr val="accent1"/>
-          </a:lnRef>
-          <a:fillRef idx="3">
-            <a:schemeClr val="accent1"/>
-          </a:fillRef>
-          <a:effectRef idx="2">
-            <a:schemeClr val="accent1"/>
-          </a:effectRef>
-          <a:fontRef idx="minor">
-            <a:schemeClr val="lt1"/>
-          </a:fontRef>
-        </p:style>
-        <p:txBody>
-          <a:bodyPr rtlCol="0" anchor="ctr"/>
-          <a:lstStyle/>
-          <a:p>
-            <a:pPr algn="ctr"/>
-            <a:endParaRPr/>
-          </a:p>
-        </p:txBody>
-      </p:sp>
-      <p:sp>
-        <p:nvSpPr>
-          <p:cNvPr id="6" name="TextBox 5"/>
-          <p:cNvSpPr txBox="1"/>
-          <p:nvPr/>
-        </p:nvSpPr>
-        <p:spPr>
-          <a:xfrm>
-            <a:off x="1828800" y="2286000"/>
-            <a:ext cx="8503920" cy="1371600"/>
-          </a:xfrm>
-          <a:prstGeom prst="rect">
-            <a:avLst/>
-          </a:prstGeom>
-          <a:noFill/>
-        </p:spPr>
-        <p:txBody>
-          <a:bodyPr wrap="square"/>
-          <a:lstStyle/>
-          <a:p>
-            <a:pPr algn="ctr">
-              <a:defRPr sz="2400" b="0">
-                <a:solidFill>
-                  <a:srgbClr val="999999"/>
-                </a:solidFill>
-                <a:latin typeface="Calibri"/>
-              </a:defRPr>
-            </a:pPr>
-            <a:r>
-              <a:t>[Diagrama: Token de 100 se destruye, se crean token de 30 y token de 70]</a:t>
-            </a:r>
-          </a:p>
-        </p:txBody>
-      </p:sp>
-      <p:sp>
-        <p:nvSpPr>
-          <p:cNvPr id="7" name="Rectangle 6"/>
-          <p:cNvSpPr/>
-          <p:nvPr/>
-        </p:nvSpPr>
-        <p:spPr>
-          <a:xfrm>
-            <a:off x="1371600" y="3840480"/>
-            <a:ext cx="9418320" cy="320040"/>
-          </a:xfrm>
-          <a:prstGeom prst="rect">
-            <a:avLst/>
-          </a:prstGeom>
-          <a:solidFill>
-            <a:srgbClr val="7C3AED"/>
-          </a:solidFill>
-          <a:ln>
-            <a:noFill/>
-          </a:ln>
-        </p:spPr>
-        <p:style>
-          <a:lnRef idx="1">
-            <a:schemeClr val="accent1"/>
-          </a:lnRef>
-          <a:fillRef idx="3">
-            <a:schemeClr val="accent1"/>
-          </a:fillRef>
-          <a:effectRef idx="2">
-            <a:schemeClr val="accent1"/>
-          </a:effectRef>
-          <a:fontRef idx="minor">
-            <a:schemeClr val="lt1"/>
-          </a:fontRef>
-        </p:style>
-        <p:txBody>
-          <a:bodyPr rtlCol="0" anchor="ctr"/>
-          <a:lstStyle/>
-          <a:p>
-            <a:pPr algn="ctr"/>
-            <a:endParaRPr/>
-          </a:p>
-        </p:txBody>
-      </p:sp>
-      <p:sp>
-        <p:nvSpPr>
-          <p:cNvPr id="8" name="TextBox 7"/>
-          <p:cNvSpPr txBox="1"/>
-          <p:nvPr/>
-        </p:nvSpPr>
-        <p:spPr>
-          <a:xfrm>
-            <a:off x="1371600" y="3840480"/>
-            <a:ext cx="9418320" cy="320040"/>
-          </a:xfrm>
-          <a:prstGeom prst="rect">
-            <a:avLst/>
-          </a:prstGeom>
-          <a:noFill/>
-        </p:spPr>
-        <p:txBody>
-          <a:bodyPr wrap="square"/>
-          <a:lstStyle/>
-          <a:p>
-            <a:pPr algn="ctr">
-              <a:defRPr sz="1300" b="1">
-                <a:solidFill>
-                  <a:srgbClr val="FFFFFF"/>
-                </a:solidFill>
-                <a:latin typeface="Calibri"/>
-              </a:defRPr>
-            </a:pPr>
-            <a:r>
-              <a:t>Prompt para IA generativa:</a:t>
-            </a:r>
-          </a:p>
-        </p:txBody>
-      </p:sp>
-      <p:sp>
-        <p:nvSpPr>
-          <p:cNvPr id="9" name="TextBox 8"/>
-          <p:cNvSpPr txBox="1"/>
-          <p:nvPr/>
-        </p:nvSpPr>
-        <p:spPr>
-          <a:xfrm>
-            <a:off x="1645920" y="4297680"/>
-            <a:ext cx="8869680" cy="914400"/>
-          </a:xfrm>
-          <a:prstGeom prst="rect">
-            <a:avLst/>
-          </a:prstGeom>
-          <a:noFill/>
-        </p:spPr>
-        <p:txBody>
-          <a:bodyPr wrap="square"/>
-          <a:lstStyle/>
-          <a:p>
-            <a:pPr algn="l">
-              <a:defRPr sz="1400" b="0">
-                <a:solidFill>
-                  <a:srgbClr val="7C3AED"/>
-                </a:solidFill>
-                <a:latin typeface="Consolas"/>
-              </a:defRPr>
-            </a:pPr>
-            <a:r>
-              <a:t>Clean infographic showing UTXO model: a single token worth 100 units splits into two tokens (30 and 70). Left side shows input token being consumed, right side shows two new output tokens created. Arrows indicate flow. Minimalist flat design, teal and white color scheme.</a:t>
-            </a:r>
-          </a:p>
-        </p:txBody>
-      </p:sp>
+      </p:pic>
     </p:spTree>
   </p:cSld>
   <p:clrMapOvr>

</xml_diff>